<commit_message>
feat: integrate celebrity sudden death slide into deck as Slide 3 (total 4 structured slides)
</commit_message>
<xml_diff>
--- a/健管45天圖片簡報-王執定.pptx
+++ b/健管45天圖片簡報-王執定.pptx
@@ -8,6 +8,7 @@
     <p:sldId id="256" r:id="rId7"/>
     <p:sldId id="257" r:id="rId9"/>
     <p:sldId id="258" r:id="rId10"/>
+    <p:sldId id="259" r:id="rId11"/>
   </p:sldIdLst>
   <p:sldSz cx="12191695" cy="6858000" type="screen4x3"/>
   <p:notesSz cx="6858000" cy="9144000"/>
@@ -694,20 +695,110 @@
           <a:lstStyle/>
           <a:p>
             <a:r>
-              <a:t>【第二幕・冒險召喚｜預計 75 秒】</a:t>
+              <a:t>【第一幕轉折・新聞震撼｜預計 40 秒】</a:t>
             </a:r>
           </a:p>
           <a:p/>
           <a:p>
             <a:r>
-              <a:t>這時候你就會常常聽到新聞報導很多名人突然猝死，有的是因為過勞，最近也有很多是他平時不抽菸、不喝酒、很養生，但還是會出事情。</a:t>
-            </a:r>
-          </a:p>
+              <a:t>這時候你就會常常聽到新聞報導很多名人突然猝死。</a:t>
+            </a:r>
+          </a:p>
+          <a:p/>
+          <a:p>
+            <a:r>
+              <a:t>一個是台灣最大文創旅店承億文旅創辦人戴俊郎，享年才 54 歲！他是大家公認的拼命三郎，心血管疾病吃了好幾年的藥，結果在母親節前夕，突發多發性腦溢血，走了。</a:t>
+            </a:r>
+          </a:p>
+          <a:p/>
+          <a:p>
+            <a:r>
+              <a:t>另一個更令人震撼：福華飯店第三代廖國宏，才 55 歲！他長期茹素、不抽菸、不喝酒，每天規律健走、打網球，極度自律養生。結果剛下飛機突然抽搐送醫，腦血栓併發腦幹出血，無法開刀，搶救十幾天還是不幸離世。</a:t>
+            </a:r>
+          </a:p>
+          <a:p/>
+          <a:p>
+            <a:r>
+              <a:t>猝死從來不挑人！身體直接停機登出！</a:t>
+            </a:r>
+          </a:p>
+          <a:p/>
           <a:p>
             <a:r>
               <a:t>聽到了這些新聞，會不會讓你覺得：『我應該要休息一下？我應該要來做做健管？』</a:t>
             </a:r>
           </a:p>
+        </p:txBody>
+      </p:sp>
+      <p:sp>
+        <p:nvSpPr>
+          <p:cNvPr id="4" name="Slide Number Placeholder 3"/>
+          <p:cNvSpPr>
+            <a:spLocks noGrp="1"/>
+          </p:cNvSpPr>
+          <p:nvPr>
+            <p:ph type="sldNum" idx="5" sz="quarter"/>
+          </p:nvPr>
+        </p:nvSpPr>
+        <p:spPr/>
+      </p:sp>
+    </p:spTree>
+  </p:cSld>
+  <p:clrMapOvr>
+    <a:masterClrMapping/>
+  </p:clrMapOvr>
+</p:notes>
+</file>
+
+<file path=ppt/notesSlides/notesSlide4.xml><?xml version="1.0" encoding="utf-8"?>
+<p:notes xmlns:a="http://schemas.openxmlformats.org/drawingml/2006/main" xmlns:p="http://schemas.openxmlformats.org/presentationml/2006/main" xmlns:r="http://schemas.openxmlformats.org/officeDocument/2006/relationships">
+  <p:cSld>
+    <p:spTree>
+      <p:nvGrpSpPr>
+        <p:cNvPr id="1" name=""/>
+        <p:cNvGrpSpPr/>
+        <p:nvPr/>
+      </p:nvGrpSpPr>
+      <p:grpSpPr>
+        <a:xfrm>
+          <a:off x="0" y="0"/>
+          <a:ext cx="0" cy="0"/>
+          <a:chOff x="0" y="0"/>
+          <a:chExt cx="0" cy="0"/>
+        </a:xfrm>
+      </p:grpSpPr>
+      <p:sp>
+        <p:nvSpPr>
+          <p:cNvPr id="2" name="Slide Image Placeholder 1"/>
+          <p:cNvSpPr>
+            <a:spLocks noGrp="1"/>
+          </p:cNvSpPr>
+          <p:nvPr>
+            <p:ph type="sldImg" idx="2"/>
+          </p:nvPr>
+        </p:nvSpPr>
+        <p:spPr/>
+      </p:sp>
+      <p:sp>
+        <p:nvSpPr>
+          <p:cNvPr id="3" name="Notes Placeholder 2"/>
+          <p:cNvSpPr>
+            <a:spLocks noGrp="1"/>
+          </p:cNvSpPr>
+          <p:nvPr>
+            <p:ph type="body" idx="3" sz="quarter"/>
+          </p:nvPr>
+        </p:nvSpPr>
+        <p:spPr/>
+        <p:txBody>
+          <a:bodyPr/>
+          <a:lstStyle/>
+          <a:p>
+            <a:r>
+              <a:t>【第二幕・冒險召喚｜預計 60 秒】</a:t>
+            </a:r>
+          </a:p>
+          <a:p/>
           <a:p>
             <a:r>
               <a:t>不會～～因為我覺得我的身體很好呀！我家的基因很健康，我平常都有做好事、累積福報，所以我不會像他們這些人一樣！</a:t>
@@ -747,7 +838,7 @@
           </a:p>
           <a:p>
             <a:r>
-              <a:t>結果有一天早上，突然頭暈目眩、心跳加速，整個身體完全提不上力，趕快去醫院檢查，結果一量血壓——直接飆到 160！</a:t>
+              <a:t>結果有一天早上，突然頭暈目眩、心跳加速，血壓飆到 160 心跳加速差點昏倒，整個身體完全提不上力，趕快去醫院檢查！</a:t>
             </a:r>
           </a:p>
           <a:p/>
@@ -3839,6 +3930,48 @@
 </file>
 
 <file path=ppt/slides/slide3.xml><?xml version="1.0" encoding="utf-8"?>
+<p:sld xmlns:a="http://schemas.openxmlformats.org/drawingml/2006/main" xmlns:p="http://schemas.openxmlformats.org/presentationml/2006/main" xmlns:r="http://schemas.openxmlformats.org/officeDocument/2006/relationships">
+  <p:cSld>
+    <p:spTree>
+      <p:nvGrpSpPr>
+        <p:cNvPr id="1" name=""/>
+        <p:cNvGrpSpPr/>
+        <p:nvPr/>
+      </p:nvGrpSpPr>
+      <p:grpSpPr/>
+      <p:pic>
+        <p:nvPicPr>
+          <p:cNvPr id="2" name="Picture 1" descr="slide_celebrity_sudden_death_v2.png"/>
+          <p:cNvPicPr>
+            <a:picLocks noChangeAspect="1"/>
+          </p:cNvPicPr>
+          <p:nvPr/>
+        </p:nvPicPr>
+        <p:blipFill>
+          <a:blip r:embed="rId2"/>
+          <a:stretch>
+            <a:fillRect/>
+          </a:stretch>
+        </p:blipFill>
+        <p:spPr>
+          <a:xfrm>
+            <a:off x="0" y="0"/>
+            <a:ext cx="12191695" cy="6858000"/>
+          </a:xfrm>
+          <a:prstGeom prst="rect">
+            <a:avLst/>
+          </a:prstGeom>
+        </p:spPr>
+      </p:pic>
+    </p:spTree>
+  </p:cSld>
+  <p:clrMapOvr>
+    <a:masterClrMapping/>
+  </p:clrMapOvr>
+</p:sld>
+</file>
+
+<file path=ppt/slides/slide4.xml><?xml version="1.0" encoding="utf-8"?>
 <p:sld xmlns:a="http://schemas.openxmlformats.org/drawingml/2006/main" xmlns:p="http://schemas.openxmlformats.org/presentationml/2006/main" xmlns:r="http://schemas.openxmlformats.org/officeDocument/2006/relationships">
   <p:cSld>
     <p:spTree>

</xml_diff>